<commit_message>
feat: add live streaming for benchmark results with SSE support
</commit_message>
<xml_diff>
--- a/docs/EOS_Payment_Improved.pptx
+++ b/docs/EOS_Payment_Improved.pptx
@@ -9870,10 +9870,19 @@
                 </a:solidFill>
                 <a:latin typeface="Aptos" panose="020B0004020202020204" pitchFamily="34" charset="0"/>
               </a:rPr>
-              <a:t>Demo, Test </a:t>
-            </a:r>
-          </a:p>
-          <a:p>
+              <a:t>Demo</a:t>
+            </a:r>
+          </a:p>
+          <a:p>
+            <a:r>
+              <a:rPr lang="en-US" sz="1100" dirty="0">
+                <a:solidFill>
+                  <a:srgbClr val="94A3B8"/>
+                </a:solidFill>
+                <a:latin typeface="Aptos" panose="020B0004020202020204" pitchFamily="34" charset="0"/>
+              </a:rPr>
+              <a:t>Demo</a:t>
+            </a:r>
             <a:r>
               <a:rPr lang="vi-VN" sz="1100" dirty="0">
                 <a:solidFill>
@@ -9881,7 +9890,7 @@
                 </a:solidFill>
                 <a:latin typeface="Aptos" panose="020B0004020202020204" pitchFamily="34" charset="0"/>
               </a:rPr>
-              <a:t>Kiểm thử, hạn chế, hướng phát triển</a:t>
+              <a:t>, hạn chế, hướng phát triển</a:t>
             </a:r>
           </a:p>
         </p:txBody>

</xml_diff>

<commit_message>
refactor: replace hardcoded account data with defaultAccounts method for improved maintainability
</commit_message>
<xml_diff>
--- a/docs/EOS_Payment_Improved.pptx
+++ b/docs/EOS_Payment_Improved.pptx
@@ -3861,25 +3861,7 @@
               <a:t>Client
 Gateway
 NODE_A  NODE_B  NODE_C
-Global </a:t>
-            </a:r>
-            <a:r>
-              <a:rPr lang="en-US" sz="2400" b="1" dirty="0" err="1">
-                <a:solidFill>
-                  <a:srgbClr val="F1F5F9"/>
-                </a:solidFill>
-                <a:latin typeface="Aptos" panose="020B0004020202020204" pitchFamily="34" charset="0"/>
-              </a:rPr>
-              <a:t>Dedup</a:t>
-            </a:r>
-            <a:r>
-              <a:rPr lang="en-US" sz="2400" b="1" dirty="0">
-                <a:solidFill>
-                  <a:srgbClr val="F1F5F9"/>
-                </a:solidFill>
-                <a:latin typeface="Aptos" panose="020B0004020202020204" pitchFamily="34" charset="0"/>
-              </a:rPr>
-              <a:t> </a:t>
+Global De-dup </a:t>
             </a:r>
           </a:p>
           <a:p>

</xml_diff>